<commit_message>
Add Live Intercept and Citizen Shield modules; align stats with official brief
Live Intercept: real-time scam-call simulation with streaming transcript,
synthetic-voice and deepfake gauges, multi-agent fusion feed, and a
full-screen mid-call intervention takeover with victim phone alerts.
Citizen Shield: WhatsApp-style conversational fraud triage in English
and Hindi with explainable verdicts and guided 1930 reporting.
Dashboard gains count-up stats, ambient background, five-module grid.
All documents updated to the MHA Rs 1,776 Cr figure from the official
problem statement.

Co-Authored-By: Claude Fable 5 <noreply@anthropic.com>
</commit_message>
<xml_diff>
--- a/docs/PRAHARI_Pitch_Deck.pptx
+++ b/docs/PRAHARI_Pitch_Deck.pptx
@@ -1913,7 +1913,7 @@
                 <a:ea typeface="Arial" pitchFamily="34" charset="-122"/>
                 <a:cs typeface="Arial" pitchFamily="34" charset="-120"/>
               </a:rPr>
-              <a:t>₹1,935 Cr</a:t>
+              <a:t>₹1,776 Cr</a:t>
             </a:r>
             <a:endParaRPr lang="en-US" sz="4400" dirty="0"/>
           </a:p>
@@ -1952,7 +1952,7 @@
                 <a:ea typeface="Calibri" pitchFamily="34" charset="-122"/>
                 <a:cs typeface="Calibri" pitchFamily="34" charset="-120"/>
               </a:rPr>
-              <a:t>lost to digital arrest scams in 2024 alone (I4C)</a:t>
+              <a:t>stolen via digital arrest scams in Jan–Sep 2024 alone (MHA)</a:t>
             </a:r>
             <a:endParaRPr lang="en-US" sz="1350" dirty="0"/>
           </a:p>
@@ -2018,7 +2018,7 @@
                 <a:ea typeface="Arial" pitchFamily="34" charset="-122"/>
                 <a:cs typeface="Arial" pitchFamily="34" charset="-120"/>
               </a:rPr>
-              <a:t>92,334</a:t>
+              <a:t>1.14 M</a:t>
             </a:r>
             <a:endParaRPr lang="en-US" sz="4400" dirty="0"/>
           </a:p>
@@ -2057,7 +2057,7 @@
                 <a:ea typeface="Calibri" pitchFamily="34" charset="-122"/>
                 <a:cs typeface="Calibri" pitchFamily="34" charset="-120"/>
               </a:rPr>
-              <a:t>digital arrest complaints — seniors targeted on hours-long video calls</a:t>
+              <a:t>cybercrime complaints in 2023, up 60% YoY — seniors targeted most</a:t>
             </a:r>
             <a:endParaRPr lang="en-US" sz="1350" dirty="0"/>
           </a:p>
@@ -3799,7 +3799,7 @@
               <a:buNone/>
             </a:pPr>
             <a:r>
-              <a:rPr lang="en-US" sz="1400" dirty="0">
+              <a:rPr lang="en-US" sz="1350" dirty="0">
                 <a:solidFill>
                   <a:srgbClr val="22D3EE"/>
                 </a:solidFill>
@@ -3807,9 +3807,9 @@
                 <a:ea typeface="Calibri" pitchFamily="34" charset="-122"/>
                 <a:cs typeface="Calibri" pitchFamily="34" charset="-120"/>
               </a:rPr>
-              <a:t>+ National Command Centre: live geospatial threat map (scam-origin zones, FICN corridors) with a fused real-time intelligence feed</a:t>
-            </a:r>
-            <a:endParaRPr lang="en-US" sz="1400" dirty="0"/>
+              <a:t>+ Command Centre threat map · Live Intercept real-time fusion demo (AI-voice + deepfake detection) · Citizen Shield chat in English &amp; Hindi — all live in the prototype</a:t>
+            </a:r>
+            <a:endParaRPr lang="en-US" sz="1350" dirty="0"/>
           </a:p>
         </p:txBody>
       </p:sp>
@@ -4436,7 +4436,7 @@
                 <a:ea typeface="Calibri" pitchFamily="34" charset="-122"/>
                 <a:cs typeface="Calibri" pitchFamily="34" charset="-120"/>
               </a:rPr>
-              <a:t>Roadmap reach</a:t>
+              <a:t>Live in the prototype</a:t>
             </a:r>
             <a:endParaRPr lang="en-US" sz="1400" dirty="0"/>
           </a:p>
@@ -4465,12 +4465,12 @@
           <a:p>
             <a:pPr indent="0" marL="0">
               <a:lnSpc>
-                <a:spcPts val="1900"/>
+                <a:spcPts val="1700"/>
               </a:lnSpc>
               <a:buNone/>
             </a:pPr>
             <a:r>
-              <a:rPr lang="en-US" sz="1250" dirty="0">
+              <a:rPr lang="en-US" sz="1200" dirty="0">
                 <a:solidFill>
                   <a:srgbClr val="DBE6F7"/>
                 </a:solidFill>
@@ -4478,9 +4478,9 @@
                 <a:ea typeface="Calibri" pitchFamily="34" charset="-122"/>
                 <a:cs typeface="Calibri" pitchFamily="34" charset="-120"/>
               </a:rPr>
-              <a:t>Citizen Shield on WhatsApp &amp; IVR in 12 regional languages · guided reporting to the 1930 helpline · on-device speech-to-text so audio never leaves the phone</a:t>
-            </a:r>
-            <a:endParaRPr lang="en-US" sz="1250" dirty="0"/>
+              <a:t>Live Intercept: full fusion pipeline on a streaming call — AI-voice detection, deepfake analysis, spoof tracing — triggering mid-call intervention. Citizen Shield chat shipping in English &amp; Hindi (12-language roadmap, WhatsApp/IVR).</a:t>
+            </a:r>
+            <a:endParaRPr lang="en-US" sz="1200" dirty="0"/>
           </a:p>
         </p:txBody>
       </p:sp>

</xml_diff>

<commit_message>
v2: real pipeline — real audio, real recordings, real STT, real FICN inference
Live Intercept: neural-TTS call (edge-tts, word-boundary sync) and REAL
FTC-evidence scam robocalls (NCSU corpus, public domain) transcribed with
Whisper word timestamps; playback drives the transcript, the classifier
scores each word live, and intervention pauses the actual audio. WebAudio
spectrum, source selector, playback-rate control, timer fallback.
Scam Shield: Live Mic mode with real speech-to-text (Web Speech API).
FICN Scanner: Real Photo Analysis tab — pure-JS CV rectification (OTSU +
min-area rect + homography), MobileNet v2 + k-NN over Kaggle real-vs-fake
corpus plus our own note photos, precomputed embeddings, 5/5 hold-out
accuracy; SVG walkthrough kept as educational tab.
scamEngine: US-agency impersonation terms so real robocalls score genuinely.
Docs: what-is-real table, demo script v3, regenerated PDF/deck.

Co-Authored-By: Claude Fable 5 <noreply@anthropic.com>
</commit_message>
<xml_diff>
--- a/docs/PRAHARI_Pitch_Deck.pptx
+++ b/docs/PRAHARI_Pitch_Deck.pptx
@@ -3807,7 +3807,7 @@
                 <a:ea typeface="Calibri" pitchFamily="34" charset="-122"/>
                 <a:cs typeface="Calibri" pitchFamily="34" charset="-120"/>
               </a:rPr>
-              <a:t>+ Command Centre threat map · Live Intercept real-time fusion demo (AI-voice + deepfake detection) · Citizen Shield chat in English &amp; Hindi — all live in the prototype</a:t>
+              <a:t>+ Command Centre threat map · Live Intercept plays REAL FTC scam recordings &amp; neural-TTS calls, intercepted live · Citizen Shield chat in English &amp; Hindi</a:t>
             </a:r>
             <a:endParaRPr lang="en-US" sz="1350" dirty="0"/>
           </a:p>
@@ -4436,7 +4436,7 @@
                 <a:ea typeface="Calibri" pitchFamily="34" charset="-122"/>
                 <a:cs typeface="Calibri" pitchFamily="34" charset="-120"/>
               </a:rPr>
-              <a:t>Live in the prototype</a:t>
+              <a:t>Real, not staged</a:t>
             </a:r>
             <a:endParaRPr lang="en-US" sz="1400" dirty="0"/>
           </a:p>
@@ -4478,7 +4478,7 @@
                 <a:ea typeface="Calibri" pitchFamily="34" charset="-122"/>
                 <a:cs typeface="Calibri" pitchFamily="34" charset="-120"/>
               </a:rPr>
-              <a:t>Live Intercept: full fusion pipeline on a streaming call — AI-voice detection, deepfake analysis, spoof tracing — triggering mid-call intervention. Citizen Shield chat shipping in English &amp; Hindi (12-language roadmap, WhatsApp/IVR).</a:t>
+              <a:t>A REAL scam robocall (FTC evidence, Whisper-transcribed) is intercepted mid-sentence with no hand-tuned trigger. Live Mic classifies the presenter's own voice via real speech-to-text. FICN model: 5/5 on held-out real note photos.</a:t>
             </a:r>
             <a:endParaRPr lang="en-US" sz="1200" dirty="0"/>
           </a:p>

</xml_diff>